<commit_message>
Auto-deploy reports for job 20260402_180643_1cuR_ot
</commit_message>
<xml_diff>
--- a/docs/reports/20260402_180643_1cuR_ot_strategic_deck.pptx
+++ b/docs/reports/20260402_180643_1cuR_ot_strategic_deck.pptx
@@ -3293,23 +3293,31 @@
               </a:defRPr>
             </a:pPr>
             <a:r>
-              <a:t>   (인용) "소셜 미디어의 과도한 필터 사용과 AI 이미지 조작에 대한 피로감이 증가하면서, 자연스러운 아름다움을 추구하는 '필터리스' 트렌드가 급부상하고 있습니다."</a:t>
+              <a:t>   (인용) "이번 크리에이티브는 'White Musk'의 본질적인 포근함과 순수함에 장원영의 신비롭고 우아한 아우라를 더하여, 시각적으로 압도적인 '궁극의 살냄새' 컨셉을 구현할 것입니다. 이는 단순한 향을 넘어, 그녀의 '럭키비키' 에너지처럼 긍정적이고 매력적인 라이프스타일을 제안합니다."</a:t>
             </a:r>
           </a:p>
           <a:p>
             <a:pPr>
-              <a:defRPr sz="1200"/>
+              <a:defRPr sz="1200">
+                <a:solidFill>
+                  <a:srgbClr val="50505A"/>
+                </a:solidFill>
+              </a:defRPr>
             </a:pPr>
             <a:r>
-              <a:t>    이번 크리에이티브는 'White Musk, 그 자체로 완벽한 장원영의 아우라'를 핵심 컨셉으로 삼습니다. 인위적인 미의 기준에서 벗어나, 장원영 본연의 깨끗하고 맑은 이미지와 그녀가 지닌 자연스러운 아름다움을 '필터리스' 트렌드에 맞춰 진정성 있게 담아낼 것입니다. 유명 셀럽과의 연출 경험을 바탕으로, 장원영님의 캐릭터를 가장 잘 표현할 수 있는 섬세한 디렉팅을 통해 White Musk의 순수함과 우아함을 시각적으로 구현합니다.</a:t>
+              <a:t>  -   유명 셀럽과의 연출 경험이 풍부한 감독님을 통해 장원영님의 캐릭터를 가장 잘 표현하는 연출을 구현할 것입니다. 그녀의 '비현실적 비율'과 '작은 얼굴, 또렷한 이목구비'를 부각하는 동시에, White Musk의 '포근하고 편안한' 이미지를 조화롭게 담아낼 수 있는 섬세한 디렉팅이 중요합니다.</a:t>
             </a:r>
           </a:p>
           <a:p>
             <a:pPr>
-              <a:defRPr sz="1200"/>
+              <a:defRPr sz="1200">
+                <a:solidFill>
+                  <a:srgbClr val="50505A"/>
+                </a:solidFill>
+              </a:defRPr>
             </a:pPr>
             <a:r>
-              <a:t>    기존 스토리보드를 참고하되, White Musk 컨셉을 자유롭게 해석하여 장원영님의 브랜딩을 극대화하는 독창적인 연출을 제안합니다. 이는 향수의 '보이지 않는 가치'를 '보이는 아름다움'으로 승화시키는 작업이 될 것입니다. 특히, 장원영님의 표정, 손짓, 시선 처리 등 미묘한 디테일을 포착하는 클로즈업과 그녀의 전신에서 뿜어져 나오는 아우라를 담는 풀 샷을 전략적으로 활용하여, White Musk가 선사하는 '섬세하면서도 강렬한 존재감'을 시청각적으로 완벽하게 전달할 것입니다.</a:t>
+              <a:t>  -   현 스토리보드를 참고하되, White Musk의 컨셉을 자유롭게 표현하여 '순수한 화이트 머스크 향'의 본질과 장원영님의 브랜딩을 살리는 연출에 집중합니다. 이는 마치 '갓 샤워하고 나온 듯한 퓨어한 코튼 향'이나 '모달 이불을 덮었을 때의 포근한 느낌'을 시각적으로 구현하여, 소비자들이 향을 직접 경험하는 듯한 몰입감을 선사할 것입니다.</a:t>
             </a:r>
           </a:p>
         </p:txBody>
@@ -3516,23 +3524,31 @@
               </a:defRPr>
             </a:pPr>
             <a:r>
-              <a:t>   (인용) "프리미엄 향수 시장은 소비자들이 경험적이고 감성적인 고급스러움에 대한 지출 의지를 높여가고 있으며, 향수는 자신을 표현할 수 있는 사치품으로 인식되고 있습니다."</a:t>
+              <a:t>   (인용) "향수는 이제 단순한 향을 넘어, '가성비 럭셔리'와 '정서적 웰빙'을 추구하는 Z세대의 강력한 자기표현 수단이자, 프리미엄 뷰티 시장의 핵심 성장 동력으로 부상하고 있습니다."</a:t>
             </a:r>
           </a:p>
           <a:p>
             <a:pPr>
-              <a:defRPr sz="1200"/>
+              <a:defRPr sz="1200">
+                <a:solidFill>
+                  <a:srgbClr val="50505A"/>
+                </a:solidFill>
+              </a:defRPr>
             </a:pPr>
             <a:r>
-              <a:t>    글로벌 뷰티 시장은 개인화된 경험과 감성적 가치를 중시하는 프리미엄 트렌드가 가속화되고 있습니다. 특히 향수 시장은 2026년부터 2031년까지 연평균 8.04%의 높은 성장률을 기록하며 1,212억 6천만 달러 규모로 성장할 것으로 전망되며, 이 중 프리미엄 부문은 전체 시장의 약 65.25%를 차지하며 가장 빠르게 성장하는 핵심 동력으로 자리매김하고 있습니다. 소비자들은 단순한 제품을 넘어, 자신을 표현하고 특별한 경험을 선사하는 향수에 기꺼이 투자하고 있습니다.</a:t>
+              <a:t>  -   글로벌 뷰티 시장에서 향수는 2024년 5,900억 달러 규모를 기록했으며, 2029년에는 6,900억 달러에 이를 것으로 예상되며, 이 중 향수 카테고리가 전체 성장의 23%를 주도할 것으로 전망됩니다. 특히 고물가 시대에 '립스틱 효과'를 넘어 '향수 효과'가 나타나며, 접근 가능한 가격으로 작은 사치를 누리고자 하는 소비 심리가 프리미엄 향수 시장의 성장을 견인하고 있습니다.</a:t>
             </a:r>
           </a:p>
           <a:p>
             <a:pPr>
-              <a:defRPr sz="1200"/>
+              <a:defRPr sz="1200">
+                <a:solidFill>
+                  <a:srgbClr val="50505A"/>
+                </a:solidFill>
+              </a:defRPr>
             </a:pPr>
             <a:r>
-              <a:t>    이러한 흐름 속에서 K-뷰티는 K-팝 아이돌의 강력한 글로벌 팬덤에 힘입어 전 세계적으로 전례 없는 성장세를 보이고 있습니다. 특히 10대에서 30대 여성 팬층은 K-팝 콘텐츠를 넘어 K-뷰티 제품 구매로 이어지는 강력한 구매력을 가지고 있으며, 이는 브랜드 인지도 제고를 넘어 실질적인 매출 증대로 직결되고 있습니다. 장원영과 같은 최정상 K-팝 아이돌은 단순한 모델을 넘어, 그들의 라이프스타일과 이미지가 곧 브랜드의 가치로 투영되는 강력한 글로벌 앰버서더 역할을 수행하고 있습니다.</a:t>
+              <a:t>  -   한국 프리미엄 향수 시장은 2019년부터 2024년 연평균(CAGR) 12.6%의 꾸준한 두 자릿수 성장세를 보이고 있으며, 2025년에는 국내 향수 시장 규모가 1조 원에 이를 것으로 예측됩니다. 이는 소비자들의 개성 중시와 니치 향수에 대한 높은 관심 증가에 기인합니다.</a:t>
             </a:r>
           </a:p>
           <a:p>
@@ -3556,23 +3572,31 @@
               </a:defRPr>
             </a:pPr>
             <a:r>
-              <a:t>   (인용) "명품 브랜드들은 제품의 품질이 아니라, 제품의 '이야기'를 팔고 있고 그 이야기를 '고객에게 투영'시키고 있습니다."</a:t>
+              <a:t>   (인용) "우리의 전략은 장원영이라는 '인간 브랜드'가 가진 독보적인 매력과 'White Musk'의 섬세한 컨셉을 완벽하게 융합하여, 감각적인 스토리텔링으로 소비자의 깊은 공감을 이끌어내고, 단순한 제품을 넘어선 라이프스타일 아이콘으로 자리매김하는 것입니다."</a:t>
             </a:r>
           </a:p>
           <a:p>
             <a:pPr>
-              <a:defRPr sz="1200"/>
+              <a:defRPr sz="1200">
+                <a:solidFill>
+                  <a:srgbClr val="50505A"/>
+                </a:solidFill>
+              </a:defRPr>
             </a:pPr>
             <a:r>
-              <a:t>    우리의 전략은 단순한 제품 광고를 넘어, White Musk의 본질적인 가치와 장원영이라는 시대의 아이콘이 지닌 독보적인 매력을 하나의 완벽한 스토리로 엮어내는 데 있습니다. 이는 소비자가 제품을 통해 '성공한 나', '아름다운 나'를 투영하고 경험하게 하는 '가치 기반 가격 책정' 전략과 일맥상통합니다.</a:t>
+              <a:t>  -   브랜드 커뮤니케이션 아이디어를 최대한으로 표현하기 위해, 장원영님의 고급스럽고 아이코닉한 무드를 White Musk 컨셉에 맞춰 섬세하게 기획하고 연출할 것입니다. 그녀의 시원하게 트인 눈매, 곧고 정제된 콧대, 안정적인 중안면 비율, 슬림한 턱선이 조화를 이루는 세련된 인상과 더불어, '럭키비키', '원영적 사고'로 대표되는 긍정적이고 자신감 있는 이미지를 활용하여 White Musk의 순수함과 포근함에 매혹적인 깊이를 더할 것입니다.</a:t>
             </a:r>
           </a:p>
           <a:p>
             <a:pPr>
-              <a:defRPr sz="1200"/>
+              <a:defRPr sz="1200">
+                <a:solidFill>
+                  <a:srgbClr val="50505A"/>
+                </a:solidFill>
+              </a:defRPr>
             </a:pPr>
             <a:r>
-              <a:t>    장원영님의 강점과 특징을 최대한으로 끌어내는 연출 아이디어는 White Musk 컨셉과 시너지를 창출하는 핵심 요소입니다. 그녀의 투명하고 자신감 있는 이미지는 White Musk가 지향하는 순수함, 우아함, 그리고 섬세하면서도 강렬한 존재감을 완벽하게 대변할 수 있습니다. 우리는 앵글, 클로즈업 등 디테일한 연출 기법을 통해 장원영님의 독보적인 비주얼과 아우라를 극대화하고, 이를 통해 White Musk의 향이 선사하는 감각적 경험을 시각적으로 구현할 것입니다. 최종적으로, 브랜드의 커뮤니케이션 아이디어를 충분히 이해하고 최대치의 표현을 확실히 전달하는 'Director’s Board'를 통해 초격차적인 결과물을 제시할 것입니다.</a:t>
+              <a:t>  -   장원영님의 장점과 특징을 극대화하는 연출 아이디어(Director's Board)를 통해, 그녀의 '비현실적 미모'와 '완성형 비주얼'을 다양한 앵글과 클로즈업으로 담아내어 제품의 프리미엄 가치를 시각적으로 전달할 것입니다. 특히, 그녀의 '동안 느낌'과 '귀여운 얼굴형'을 살리면서도 White Musk가 지닌 우아하고 포근한 분위기를 동시에 표현할 수 있는 연출에 집중합니다.</a:t>
             </a:r>
           </a:p>
         </p:txBody>

</xml_diff>